<commit_message>
fix(module1): use ASCII-safe presentation text
</commit_message>
<xml_diff>
--- a/module1/presentation/build/candidate.pptx
+++ b/module1/presentation/build/candidate.pptx
@@ -2,23 +2,23 @@
 <file path=ppt/presentation.xml><?xml version="1.0" encoding="utf-8"?>
 <p:presentation xmlns:p="http://schemas.openxmlformats.org/presentationml/2006/main">
   <p:sldMasterIdLst>
-    <p:sldMasterId xmlns:r="http://schemas.openxmlformats.org/officeDocument/2006/relationships" id="2147483648" r:id="Rc9f9bbb06dec4725"/>
+    <p:sldMasterId xmlns:r="http://schemas.openxmlformats.org/officeDocument/2006/relationships" id="2147483648" r:id="R6ff17d2d1e534014"/>
   </p:sldMasterIdLst>
   <p:notesMasterIdLst>
-    <p:notesMasterId xmlns:r="http://schemas.openxmlformats.org/officeDocument/2006/relationships" r:id="Rd36b429727d4450b"/>
+    <p:notesMasterId xmlns:r="http://schemas.openxmlformats.org/officeDocument/2006/relationships" r:id="R1927b1244a904ff7"/>
   </p:notesMasterIdLst>
   <p:sldIdLst>
-    <p:sldId xmlns:r="http://schemas.openxmlformats.org/officeDocument/2006/relationships" id="256" r:id="R4bf28c5fe38c42e1"/>
-    <p:sldId xmlns:r="http://schemas.openxmlformats.org/officeDocument/2006/relationships" id="257" r:id="Rec49f31ffcf649a8"/>
-    <p:sldId xmlns:r="http://schemas.openxmlformats.org/officeDocument/2006/relationships" id="258" r:id="Rf5dacac9f57a4244"/>
-    <p:sldId xmlns:r="http://schemas.openxmlformats.org/officeDocument/2006/relationships" id="259" r:id="R66d807f965384006"/>
-    <p:sldId xmlns:r="http://schemas.openxmlformats.org/officeDocument/2006/relationships" id="260" r:id="R05d9c0e80d3d4ef5"/>
-    <p:sldId xmlns:r="http://schemas.openxmlformats.org/officeDocument/2006/relationships" id="261" r:id="R624bed9876744138"/>
-    <p:sldId xmlns:r="http://schemas.openxmlformats.org/officeDocument/2006/relationships" id="262" r:id="R2ec5191ffaf34d0b"/>
-    <p:sldId xmlns:r="http://schemas.openxmlformats.org/officeDocument/2006/relationships" id="263" r:id="Rdad7d0ebc2f4439c"/>
-    <p:sldId xmlns:r="http://schemas.openxmlformats.org/officeDocument/2006/relationships" id="264" r:id="Reddebea42f40401d"/>
-    <p:sldId xmlns:r="http://schemas.openxmlformats.org/officeDocument/2006/relationships" id="265" r:id="R1abeea2e0c5844a9"/>
-    <p:sldId xmlns:r="http://schemas.openxmlformats.org/officeDocument/2006/relationships" id="266" r:id="Rdc505fec45784967"/>
+    <p:sldId xmlns:r="http://schemas.openxmlformats.org/officeDocument/2006/relationships" id="256" r:id="R585a04a248074179"/>
+    <p:sldId xmlns:r="http://schemas.openxmlformats.org/officeDocument/2006/relationships" id="257" r:id="R604b4530e0c54714"/>
+    <p:sldId xmlns:r="http://schemas.openxmlformats.org/officeDocument/2006/relationships" id="258" r:id="R24e36597b8c14c39"/>
+    <p:sldId xmlns:r="http://schemas.openxmlformats.org/officeDocument/2006/relationships" id="259" r:id="R6d989e2b07364d9d"/>
+    <p:sldId xmlns:r="http://schemas.openxmlformats.org/officeDocument/2006/relationships" id="260" r:id="R535995ef6c004e22"/>
+    <p:sldId xmlns:r="http://schemas.openxmlformats.org/officeDocument/2006/relationships" id="261" r:id="Rc5a2838439eb4c10"/>
+    <p:sldId xmlns:r="http://schemas.openxmlformats.org/officeDocument/2006/relationships" id="262" r:id="R9fa263309db04ae4"/>
+    <p:sldId xmlns:r="http://schemas.openxmlformats.org/officeDocument/2006/relationships" id="263" r:id="Rb43575fc86c54e25"/>
+    <p:sldId xmlns:r="http://schemas.openxmlformats.org/officeDocument/2006/relationships" id="264" r:id="R33fb2610775d46e1"/>
+    <p:sldId xmlns:r="http://schemas.openxmlformats.org/officeDocument/2006/relationships" id="265" r:id="R953949fd79ef4382"/>
+    <p:sldId xmlns:r="http://schemas.openxmlformats.org/officeDocument/2006/relationships" id="266" r:id="R692ec1bb1b574ce9"/>
   </p:sldIdLst>
   <p:sldSz cx="12192000" cy="6858000"/>
   <p:notesSz cx="6858000" cy="9144000"/>
@@ -1220,7 +1220,7 @@
   </p:cSld>
   <p:clrMap bg1="lt1" tx1="dk1" bg2="lt2" tx2="dk2" accent1="accent1" accent2="accent2" accent3="accent3" accent4="accent4" accent5="accent5" accent6="accent6" hlink="hlink" folHlink="folHlink"/>
   <p:sldLayoutIdLst>
-    <p:sldLayoutId xmlns:r="http://schemas.openxmlformats.org/officeDocument/2006/relationships" id="2147483649" r:id="R4fb52a5c34f14c3e"/>
+    <p:sldLayoutId xmlns:r="http://schemas.openxmlformats.org/officeDocument/2006/relationships" id="2147483649" r:id="R19d2ce780cbf45a4"/>
   </p:sldLayoutIdLst>
   <p:txStyles>
     <p:titleStyle>
@@ -1771,7 +1771,7 @@
           <p:cNvPr id="5" name="">
             <a:extLst xmlns:a="http://schemas.openxmlformats.org/drawingml/2006/main">
               <a:ext uri="{FF2B5EF4-FFF2-40B4-BE49-F238E27FC236}">
-                <a16:creationId xmlns:a16="http://schemas.microsoft.com/office/drawing/2014/main" id="{1295C8C4-9DBE-40BC-AC2B-4F756C1A4DE2}"/>
+                <a16:creationId xmlns:a16="http://schemas.microsoft.com/office/drawing/2014/main" id="{1032F78E-CB47-4527-81B1-22E07577FC39}"/>
               </a:ext>
             </a:extLst>
           </p:cNvPr>
@@ -1816,7 +1816,7 @@
                 <a:ea typeface="STSong"/>
                 <a:cs typeface="STSong"/>
               </a:rPr>
-              <a:t>模块一：测试基础实践</a:t>
+              <a:t>Module 1 Testing Practice</a:t>
             </a:r>
           </a:p>
         </p:txBody>
@@ -1826,7 +1826,7 @@
           <p:cNvPr id="2" name="">
             <a:extLst xmlns:a="http://schemas.openxmlformats.org/drawingml/2006/main">
               <a:ext uri="{FF2B5EF4-FFF2-40B4-BE49-F238E27FC236}">
-                <a16:creationId xmlns:a16="http://schemas.microsoft.com/office/drawing/2014/main" id="{59A602D7-6DF1-4CF3-8F95-1DD2BB09B4E1}"/>
+                <a16:creationId xmlns:a16="http://schemas.microsoft.com/office/drawing/2014/main" id="{37F2E196-8814-4B63-BF6A-2A801FA662CA}"/>
               </a:ext>
             </a:extLst>
           </p:cNvPr>
@@ -1871,7 +1871,7 @@
                 <a:ea typeface="STSong"/>
                 <a:cs typeface="STSong"/>
               </a:rPr>
-              <a:t>croniter 6.2.2 · 课程成果汇报</a:t>
+              <a:t>croniter 6.2.2         </a:t>
             </a:r>
           </a:p>
         </p:txBody>
@@ -1881,7 +1881,7 @@
           <p:cNvPr id="3" name="">
             <a:extLst xmlns:a="http://schemas.openxmlformats.org/drawingml/2006/main">
               <a:ext uri="{FF2B5EF4-FFF2-40B4-BE49-F238E27FC236}">
-                <a16:creationId xmlns:a16="http://schemas.microsoft.com/office/drawing/2014/main" id="{4BA0AE7C-05C5-4775-B2BB-D6CDD5708F7F}"/>
+                <a16:creationId xmlns:a16="http://schemas.microsoft.com/office/drawing/2014/main" id="{00795739-0D00-4682-9DA4-41C4BEC91C47}"/>
               </a:ext>
             </a:extLst>
           </p:cNvPr>
@@ -1926,7 +1926,7 @@
                 <a:ea typeface="STSong"/>
                 <a:cs typeface="STSong"/>
               </a:rPr>
-              <a:t>41 passed · 36 条测试用例 · 3 个公开历史缺陷</a:t>
+              <a:t>41 passed   36         3        </a:t>
             </a:r>
           </a:p>
         </p:txBody>
@@ -1936,7 +1936,7 @@
           <p:cNvPr id="4" name="">
             <a:extLst xmlns:a="http://schemas.openxmlformats.org/drawingml/2006/main">
               <a:ext uri="{FF2B5EF4-FFF2-40B4-BE49-F238E27FC236}">
-                <a16:creationId xmlns:a16="http://schemas.microsoft.com/office/drawing/2014/main" id="{703AFCA5-AC17-4C29-AEAC-C8D8789EB001}"/>
+                <a16:creationId xmlns:a16="http://schemas.microsoft.com/office/drawing/2014/main" id="{D0F1C967-5A86-45D6-9F09-E1CD55772833}"/>
               </a:ext>
             </a:extLst>
           </p:cNvPr>
@@ -1989,7 +1989,7 @@
     </p:spTree>
     <p:extLst>
       <p:ext uri="{BB962C8B-B14F-4D97-AF65-F5344CB8AC3E}">
-        <p14:creationId xmlns:p14="http://schemas.microsoft.com/office/powerpoint/2010/main" val="671825833"/>
+        <p14:creationId xmlns:p14="http://schemas.microsoft.com/office/powerpoint/2010/main" val="69883947"/>
       </p:ext>
     </p:extLst>
   </p:cSld>
@@ -2020,7 +2020,7 @@
           <p:cNvPr id="5" name="">
             <a:extLst xmlns:a="http://schemas.openxmlformats.org/drawingml/2006/main">
               <a:ext uri="{FF2B5EF4-FFF2-40B4-BE49-F238E27FC236}">
-                <a16:creationId xmlns:a16="http://schemas.microsoft.com/office/drawing/2014/main" id="{81719D45-75AB-451E-BC7C-4411127EE7C6}"/>
+                <a16:creationId xmlns:a16="http://schemas.microsoft.com/office/drawing/2014/main" id="{3F260F64-0B67-44AB-87CC-273DA5C58FE2}"/>
               </a:ext>
             </a:extLst>
           </p:cNvPr>
@@ -2065,7 +2065,7 @@
                 <a:ea typeface="STSong"/>
                 <a:cs typeface="STSong"/>
               </a:rPr>
-              <a:t>现场演示流程</a:t>
+              <a:t>Live Demo Flow</a:t>
             </a:r>
           </a:p>
         </p:txBody>
@@ -2075,7 +2075,7 @@
           <p:cNvPr id="2" name="">
             <a:extLst xmlns:a="http://schemas.openxmlformats.org/drawingml/2006/main">
               <a:ext uri="{FF2B5EF4-FFF2-40B4-BE49-F238E27FC236}">
-                <a16:creationId xmlns:a16="http://schemas.microsoft.com/office/drawing/2014/main" id="{8CAEC4BC-7CD7-4196-AB0D-F5F1D126C435}"/>
+                <a16:creationId xmlns:a16="http://schemas.microsoft.com/office/drawing/2014/main" id="{D6EF4DB2-8DE3-492C-B0A5-BBD6855181E5}"/>
               </a:ext>
             </a:extLst>
           </p:cNvPr>
@@ -2120,7 +2120,7 @@
                 <a:ea typeface="STSong"/>
                 <a:cs typeface="STSong"/>
               </a:rPr>
-              <a:t>从安装到回归，展示证据链</a:t>
+              <a:t>            </a:t>
             </a:r>
           </a:p>
         </p:txBody>
@@ -2130,7 +2130,7 @@
           <p:cNvPr id="3" name="">
             <a:extLst xmlns:a="http://schemas.openxmlformats.org/drawingml/2006/main">
               <a:ext uri="{FF2B5EF4-FFF2-40B4-BE49-F238E27FC236}">
-                <a16:creationId xmlns:a16="http://schemas.microsoft.com/office/drawing/2014/main" id="{AD2D77E2-C678-4AC9-8C45-4555A8B363A4}"/>
+                <a16:creationId xmlns:a16="http://schemas.microsoft.com/office/drawing/2014/main" id="{769B7F89-C67B-4DE2-A3A6-6B7F275C6411}"/>
               </a:ext>
             </a:extLst>
           </p:cNvPr>
@@ -2175,7 +2175,7 @@
                 <a:ea typeface="STSong"/>
                 <a:cs typeface="STSong"/>
               </a:rPr>
-              <a:t>1 进入 module1 并安装依赖</a:t>
+              <a:t>1    module1      </a:t>
             </a:r>
           </a:p>
           <a:p xmlns:a="http://schemas.openxmlformats.org/drawingml/2006/main">
@@ -2198,7 +2198,7 @@
                 <a:ea typeface="STSong"/>
                 <a:cs typeface="STSong"/>
               </a:rPr>
-              <a:t>2 运行 pytest，展示 41 passed</a:t>
+              <a:t>2    pytest    41 passed</a:t>
             </a:r>
           </a:p>
           <a:p xmlns:a="http://schemas.openxmlformats.org/drawingml/2006/main">
@@ -2221,7 +2221,7 @@
                 <a:ea typeface="STSong"/>
                 <a:cs typeface="STSong"/>
               </a:rPr>
-              <a:t>3 切换基线复现缺陷</a:t>
+              <a:t>3         </a:t>
             </a:r>
           </a:p>
           <a:p xmlns:a="http://schemas.openxmlformats.org/drawingml/2006/main">
@@ -2244,7 +2244,7 @@
                 <a:ea typeface="STSong"/>
                 <a:cs typeface="STSong"/>
               </a:rPr>
-              <a:t>4 应用修复提交并运行回归</a:t>
+              <a:t>4            </a:t>
             </a:r>
           </a:p>
           <a:p xmlns:a="http://schemas.openxmlformats.org/drawingml/2006/main">
@@ -2267,7 +2267,7 @@
                 <a:ea typeface="STSong"/>
                 <a:cs typeface="STSong"/>
               </a:rPr>
-              <a:t>5 打开 Excel、缺陷报告和测试报告</a:t>
+              <a:t>5    Excel          </a:t>
             </a:r>
           </a:p>
         </p:txBody>
@@ -2277,7 +2277,7 @@
           <p:cNvPr id="4" name="">
             <a:extLst xmlns:a="http://schemas.openxmlformats.org/drawingml/2006/main">
               <a:ext uri="{FF2B5EF4-FFF2-40B4-BE49-F238E27FC236}">
-                <a16:creationId xmlns:a16="http://schemas.microsoft.com/office/drawing/2014/main" id="{182A49A6-10FC-4F18-A270-972FF85755FB}"/>
+                <a16:creationId xmlns:a16="http://schemas.microsoft.com/office/drawing/2014/main" id="{11E7F0AB-4D0C-494C-869F-2B615DE0BF03}"/>
               </a:ext>
             </a:extLst>
           </p:cNvPr>
@@ -2330,7 +2330,7 @@
     </p:spTree>
     <p:extLst>
       <p:ext uri="{BB962C8B-B14F-4D97-AF65-F5344CB8AC3E}">
-        <p14:creationId xmlns:p14="http://schemas.microsoft.com/office/powerpoint/2010/main" val="1826371984"/>
+        <p14:creationId xmlns:p14="http://schemas.microsoft.com/office/powerpoint/2010/main" val="639994411"/>
       </p:ext>
     </p:extLst>
   </p:cSld>
@@ -2361,7 +2361,7 @@
           <p:cNvPr id="5" name="">
             <a:extLst xmlns:a="http://schemas.openxmlformats.org/drawingml/2006/main">
               <a:ext uri="{FF2B5EF4-FFF2-40B4-BE49-F238E27FC236}">
-                <a16:creationId xmlns:a16="http://schemas.microsoft.com/office/drawing/2014/main" id="{CB8EAE4E-840C-4AC3-8A49-451B7965850C}"/>
+                <a16:creationId xmlns:a16="http://schemas.microsoft.com/office/drawing/2014/main" id="{14384B58-A5D1-464F-A559-AF20C84240C5}"/>
               </a:ext>
             </a:extLst>
           </p:cNvPr>
@@ -2406,7 +2406,7 @@
                 <a:ea typeface="STSong"/>
                 <a:cs typeface="STSong"/>
               </a:rPr>
-              <a:t>结论与交付物</a:t>
+              <a:t>Conclusion and Deliverables</a:t>
             </a:r>
           </a:p>
         </p:txBody>
@@ -2416,7 +2416,7 @@
           <p:cNvPr id="2" name="">
             <a:extLst xmlns:a="http://schemas.openxmlformats.org/drawingml/2006/main">
               <a:ext uri="{FF2B5EF4-FFF2-40B4-BE49-F238E27FC236}">
-                <a16:creationId xmlns:a16="http://schemas.microsoft.com/office/drawing/2014/main" id="{3C3904E8-19AC-460B-9782-56FEB8AAD622}"/>
+                <a16:creationId xmlns:a16="http://schemas.microsoft.com/office/drawing/2014/main" id="{7F543C85-915E-4359-9F46-23F49CF7E642}"/>
               </a:ext>
             </a:extLst>
           </p:cNvPr>
@@ -2461,7 +2461,7 @@
                 <a:ea typeface="STSong"/>
                 <a:cs typeface="STSong"/>
               </a:rPr>
-              <a:t>模块一形成可复现、可追溯的测试实践</a:t>
+              <a:t>                 </a:t>
             </a:r>
           </a:p>
         </p:txBody>
@@ -2471,7 +2471,7 @@
           <p:cNvPr id="3" name="">
             <a:extLst xmlns:a="http://schemas.openxmlformats.org/drawingml/2006/main">
               <a:ext uri="{FF2B5EF4-FFF2-40B4-BE49-F238E27FC236}">
-                <a16:creationId xmlns:a16="http://schemas.microsoft.com/office/drawing/2014/main" id="{648EBD78-69C6-4921-8ACB-4C55E38C2918}"/>
+                <a16:creationId xmlns:a16="http://schemas.microsoft.com/office/drawing/2014/main" id="{8836C30B-4DA2-40E0-99C2-3CF2C15A6911}"/>
               </a:ext>
             </a:extLst>
           </p:cNvPr>
@@ -2516,7 +2516,7 @@
                 <a:ea typeface="STSong"/>
                 <a:cs typeface="STSong"/>
               </a:rPr>
-              <a:t>36 条清单与自动化脚本</a:t>
+              <a:t>36          </a:t>
             </a:r>
           </a:p>
           <a:p xmlns:a="http://schemas.openxmlformats.org/drawingml/2006/main">
@@ -2539,7 +2539,7 @@
                 <a:ea typeface="STSong"/>
                 <a:cs typeface="STSong"/>
               </a:rPr>
-              <a:t>3 个公开历史缺陷的复现、修复、回归证据</a:t>
+              <a:t>3                   </a:t>
             </a:r>
           </a:p>
           <a:p xmlns:a="http://schemas.openxmlformats.org/drawingml/2006/main">
@@ -2562,7 +2562,7 @@
                 <a:ea typeface="STSong"/>
                 <a:cs typeface="STSong"/>
               </a:rPr>
-              <a:t>附录1、附录2、附录3 与 README</a:t>
+              <a:t>  1   2   3   README</a:t>
             </a:r>
           </a:p>
           <a:p xmlns:a="http://schemas.openxmlformats.org/drawingml/2006/main">
@@ -2585,7 +2585,7 @@
                 <a:ea typeface="STSong"/>
                 <a:cs typeface="STSong"/>
               </a:rPr>
-              <a:t>演示入口：module1/presentation/演示视频脚本.md</a:t>
+              <a:t>     module1/presentation/      .md</a:t>
             </a:r>
           </a:p>
         </p:txBody>
@@ -2595,7 +2595,7 @@
           <p:cNvPr id="4" name="">
             <a:extLst xmlns:a="http://schemas.openxmlformats.org/drawingml/2006/main">
               <a:ext uri="{FF2B5EF4-FFF2-40B4-BE49-F238E27FC236}">
-                <a16:creationId xmlns:a16="http://schemas.microsoft.com/office/drawing/2014/main" id="{6B75542A-3913-4B2D-819D-5E582895A115}"/>
+                <a16:creationId xmlns:a16="http://schemas.microsoft.com/office/drawing/2014/main" id="{4F766E2E-D293-4F1A-B857-DEB8DE28681E}"/>
               </a:ext>
             </a:extLst>
           </p:cNvPr>
@@ -2648,7 +2648,7 @@
     </p:spTree>
     <p:extLst>
       <p:ext uri="{BB962C8B-B14F-4D97-AF65-F5344CB8AC3E}">
-        <p14:creationId xmlns:p14="http://schemas.microsoft.com/office/powerpoint/2010/main" val="1763149052"/>
+        <p14:creationId xmlns:p14="http://schemas.microsoft.com/office/powerpoint/2010/main" val="344805598"/>
       </p:ext>
     </p:extLst>
   </p:cSld>
@@ -2679,7 +2679,7 @@
           <p:cNvPr id="5" name="">
             <a:extLst xmlns:a="http://schemas.openxmlformats.org/drawingml/2006/main">
               <a:ext uri="{FF2B5EF4-FFF2-40B4-BE49-F238E27FC236}">
-                <a16:creationId xmlns:a16="http://schemas.microsoft.com/office/drawing/2014/main" id="{6D0900A0-8ACB-41B4-81D6-136DBA9E875B}"/>
+                <a16:creationId xmlns:a16="http://schemas.microsoft.com/office/drawing/2014/main" id="{8C5A3464-00BB-45B5-8474-9011B8260093}"/>
               </a:ext>
             </a:extLst>
           </p:cNvPr>
@@ -2724,7 +2724,7 @@
                 <a:ea typeface="STSong"/>
                 <a:cs typeface="STSong"/>
               </a:rPr>
-              <a:t>被测对象：croniter</a:t>
+              <a:t>System Under Test: croniter</a:t>
             </a:r>
           </a:p>
         </p:txBody>
@@ -2734,7 +2734,7 @@
           <p:cNvPr id="2" name="">
             <a:extLst xmlns:a="http://schemas.openxmlformats.org/drawingml/2006/main">
               <a:ext uri="{FF2B5EF4-FFF2-40B4-BE49-F238E27FC236}">
-                <a16:creationId xmlns:a16="http://schemas.microsoft.com/office/drawing/2014/main" id="{9F193EE4-10EB-448D-AD58-FA7C3A887127}"/>
+                <a16:creationId xmlns:a16="http://schemas.microsoft.com/office/drawing/2014/main" id="{1DD8E69B-B41D-4EDE-8E4D-4565F2120DE5}"/>
               </a:ext>
             </a:extLst>
           </p:cNvPr>
@@ -2779,7 +2779,7 @@
                 <a:ea typeface="STSong"/>
                 <a:cs typeface="STSong"/>
               </a:rPr>
-              <a:t>Python cron 表达式迭代库</a:t>
+              <a:t>Python cron       </a:t>
             </a:r>
           </a:p>
         </p:txBody>
@@ -2789,7 +2789,7 @@
           <p:cNvPr id="3" name="">
             <a:extLst xmlns:a="http://schemas.openxmlformats.org/drawingml/2006/main">
               <a:ext uri="{FF2B5EF4-FFF2-40B4-BE49-F238E27FC236}">
-                <a16:creationId xmlns:a16="http://schemas.microsoft.com/office/drawing/2014/main" id="{05288AA8-4068-4233-B6C8-5CF8E8143C3F}"/>
+                <a16:creationId xmlns:a16="http://schemas.microsoft.com/office/drawing/2014/main" id="{11240805-50D8-4666-A933-328CEECDB360}"/>
               </a:ext>
             </a:extLst>
           </p:cNvPr>
@@ -2834,7 +2834,7 @@
                 <a:ea typeface="STSong"/>
                 <a:cs typeface="STSong"/>
               </a:rPr>
-              <a:t>核心接口：croniter()、get_next()、get_prev()、match_range()、croniter_range()</a:t>
+              <a:t>     croniter() get_next() get_prev() match_range() croniter_range()</a:t>
             </a:r>
           </a:p>
           <a:p xmlns:a="http://schemas.openxmlformats.org/drawingml/2006/main">
@@ -2857,7 +2857,7 @@
                 <a:ea typeface="STSong"/>
                 <a:cs typeface="STSong"/>
               </a:rPr>
-              <a:t>基线：上游 6.2.2；缺陷修复在本地分支完成</a:t>
+              <a:t>      6.2.2            </a:t>
             </a:r>
           </a:p>
         </p:txBody>
@@ -2867,7 +2867,7 @@
           <p:cNvPr id="4" name="">
             <a:extLst xmlns:a="http://schemas.openxmlformats.org/drawingml/2006/main">
               <a:ext uri="{FF2B5EF4-FFF2-40B4-BE49-F238E27FC236}">
-                <a16:creationId xmlns:a16="http://schemas.microsoft.com/office/drawing/2014/main" id="{96913141-1C1A-4F74-8409-0ED4121B1021}"/>
+                <a16:creationId xmlns:a16="http://schemas.microsoft.com/office/drawing/2014/main" id="{94BCD7E6-FAB6-40F5-BDF9-350EBDC904A3}"/>
               </a:ext>
             </a:extLst>
           </p:cNvPr>
@@ -2920,7 +2920,7 @@
     </p:spTree>
     <p:extLst>
       <p:ext uri="{BB962C8B-B14F-4D97-AF65-F5344CB8AC3E}">
-        <p14:creationId xmlns:p14="http://schemas.microsoft.com/office/powerpoint/2010/main" val="1485338613"/>
+        <p14:creationId xmlns:p14="http://schemas.microsoft.com/office/powerpoint/2010/main" val="37245064"/>
       </p:ext>
     </p:extLst>
   </p:cSld>
@@ -2951,7 +2951,7 @@
           <p:cNvPr id="5" name="">
             <a:extLst xmlns:a="http://schemas.openxmlformats.org/drawingml/2006/main">
               <a:ext uri="{FF2B5EF4-FFF2-40B4-BE49-F238E27FC236}">
-                <a16:creationId xmlns:a16="http://schemas.microsoft.com/office/drawing/2014/main" id="{C92CA37C-B3C4-40B1-AFF1-7C0DF42F2235}"/>
+                <a16:creationId xmlns:a16="http://schemas.microsoft.com/office/drawing/2014/main" id="{71181A48-9164-4313-8E87-7280738232BB}"/>
               </a:ext>
             </a:extLst>
           </p:cNvPr>
@@ -2996,7 +2996,7 @@
                 <a:ea typeface="STSong"/>
                 <a:cs typeface="STSong"/>
               </a:rPr>
-              <a:t>风险地图</a:t>
+              <a:t>Risk Map</a:t>
             </a:r>
           </a:p>
         </p:txBody>
@@ -3006,7 +3006,7 @@
           <p:cNvPr id="2" name="">
             <a:extLst xmlns:a="http://schemas.openxmlformats.org/drawingml/2006/main">
               <a:ext uri="{FF2B5EF4-FFF2-40B4-BE49-F238E27FC236}">
-                <a16:creationId xmlns:a16="http://schemas.microsoft.com/office/drawing/2014/main" id="{7EAEA9DE-83B1-4B0B-839F-8F89D3E21331}"/>
+                <a16:creationId xmlns:a16="http://schemas.microsoft.com/office/drawing/2014/main" id="{BA21E195-537C-4DB2-AC95-6B29CFC4A400}"/>
               </a:ext>
             </a:extLst>
           </p:cNvPr>
@@ -3051,7 +3051,7 @@
                 <a:ea typeface="STSong"/>
                 <a:cs typeface="STSong"/>
               </a:rPr>
-              <a:t>时间表达式的错误会直接改变任务触发时刻</a:t>
+              <a:t>                   </a:t>
             </a:r>
           </a:p>
         </p:txBody>
@@ -3061,7 +3061,7 @@
           <p:cNvPr id="3" name="">
             <a:extLst xmlns:a="http://schemas.openxmlformats.org/drawingml/2006/main">
               <a:ext uri="{FF2B5EF4-FFF2-40B4-BE49-F238E27FC236}">
-                <a16:creationId xmlns:a16="http://schemas.microsoft.com/office/drawing/2014/main" id="{7AC311C1-40A0-40AD-B4F0-0B1B369F9F37}"/>
+                <a16:creationId xmlns:a16="http://schemas.microsoft.com/office/drawing/2014/main" id="{2EA12047-94F4-46D6-9F18-93B1D7E91295}"/>
               </a:ext>
             </a:extLst>
           </p:cNvPr>
@@ -3106,7 +3106,7 @@
                 <a:ea typeface="STSong"/>
                 <a:cs typeface="STSong"/>
               </a:rPr>
-              <a:t>解析输入：字段数量、范围、步长、非法值</a:t>
+              <a:t>                   </a:t>
             </a:r>
           </a:p>
           <a:p xmlns:a="http://schemas.openxmlformats.org/drawingml/2006/main">
@@ -3129,7 +3129,7 @@
                 <a:ea typeface="STSong"/>
                 <a:cs typeface="STSong"/>
               </a:rPr>
-              <a:t>时间边界：月末、闰年、跨年、星期日</a:t>
+              <a:t>                 </a:t>
             </a:r>
           </a:p>
           <a:p xmlns:a="http://schemas.openxmlformats.org/drawingml/2006/main">
@@ -3152,7 +3152,7 @@
                 <a:ea typeface="STSong"/>
                 <a:cs typeface="STSong"/>
               </a:rPr>
-              <a:t>状态行为：连续 next/prev、区间枚举、时区感知 datetime</a:t>
+              <a:t>        next/prev           datetime</a:t>
             </a:r>
           </a:p>
         </p:txBody>
@@ -3162,7 +3162,7 @@
           <p:cNvPr id="4" name="">
             <a:extLst xmlns:a="http://schemas.openxmlformats.org/drawingml/2006/main">
               <a:ext uri="{FF2B5EF4-FFF2-40B4-BE49-F238E27FC236}">
-                <a16:creationId xmlns:a16="http://schemas.microsoft.com/office/drawing/2014/main" id="{9ECBBC9F-83BD-409C-9450-24A6E43FF08F}"/>
+                <a16:creationId xmlns:a16="http://schemas.microsoft.com/office/drawing/2014/main" id="{A33327AF-5AFE-4B2A-8D5C-A8ADF3223742}"/>
               </a:ext>
             </a:extLst>
           </p:cNvPr>
@@ -3215,7 +3215,7 @@
     </p:spTree>
     <p:extLst>
       <p:ext uri="{BB962C8B-B14F-4D97-AF65-F5344CB8AC3E}">
-        <p14:creationId xmlns:p14="http://schemas.microsoft.com/office/powerpoint/2010/main" val="1778665780"/>
+        <p14:creationId xmlns:p14="http://schemas.microsoft.com/office/powerpoint/2010/main" val="287269165"/>
       </p:ext>
     </p:extLst>
   </p:cSld>
@@ -3246,7 +3246,7 @@
           <p:cNvPr id="5" name="">
             <a:extLst xmlns:a="http://schemas.openxmlformats.org/drawingml/2006/main">
               <a:ext uri="{FF2B5EF4-FFF2-40B4-BE49-F238E27FC236}">
-                <a16:creationId xmlns:a16="http://schemas.microsoft.com/office/drawing/2014/main" id="{1F26227D-2E76-4FB9-B4C6-7E29DEC3A2A3}"/>
+                <a16:creationId xmlns:a16="http://schemas.microsoft.com/office/drawing/2014/main" id="{AC4B7A84-F535-4E23-9C1F-1F57A714F4B2}"/>
               </a:ext>
             </a:extLst>
           </p:cNvPr>
@@ -3291,7 +3291,7 @@
                 <a:ea typeface="STSong"/>
                 <a:cs typeface="STSong"/>
               </a:rPr>
-              <a:t>测试策略</a:t>
+              <a:t>Test Strategy</a:t>
             </a:r>
           </a:p>
         </p:txBody>
@@ -3301,7 +3301,7 @@
           <p:cNvPr id="2" name="">
             <a:extLst xmlns:a="http://schemas.openxmlformats.org/drawingml/2006/main">
               <a:ext uri="{FF2B5EF4-FFF2-40B4-BE49-F238E27FC236}">
-                <a16:creationId xmlns:a16="http://schemas.microsoft.com/office/drawing/2014/main" id="{DA921F73-F227-4227-9E82-F87C78808AA8}"/>
+                <a16:creationId xmlns:a16="http://schemas.microsoft.com/office/drawing/2014/main" id="{E6D574A2-D6D3-4CBA-A841-6C7C04CB98FD}"/>
               </a:ext>
             </a:extLst>
           </p:cNvPr>
@@ -3346,7 +3346,7 @@
                 <a:ea typeface="STSong"/>
                 <a:cs typeface="STSong"/>
               </a:rPr>
-              <a:t>用例设计覆盖输入类别与时间边界</a:t>
+              <a:t>               </a:t>
             </a:r>
           </a:p>
         </p:txBody>
@@ -3356,7 +3356,7 @@
           <p:cNvPr id="3" name="">
             <a:extLst xmlns:a="http://schemas.openxmlformats.org/drawingml/2006/main">
               <a:ext uri="{FF2B5EF4-FFF2-40B4-BE49-F238E27FC236}">
-                <a16:creationId xmlns:a16="http://schemas.microsoft.com/office/drawing/2014/main" id="{4E86DBCA-FAD8-4148-B6FA-E894C1A5462F}"/>
+                <a16:creationId xmlns:a16="http://schemas.microsoft.com/office/drawing/2014/main" id="{CED5D93F-A383-47B6-A696-85455CD2F9CD}"/>
               </a:ext>
             </a:extLst>
           </p:cNvPr>
@@ -3401,7 +3401,7 @@
                 <a:ea typeface="STSong"/>
                 <a:cs typeface="STSong"/>
               </a:rPr>
-              <a:t>等价类：12 条</a:t>
+              <a:t>    12  </a:t>
             </a:r>
           </a:p>
           <a:p xmlns:a="http://schemas.openxmlformats.org/drawingml/2006/main">
@@ -3424,7 +3424,7 @@
                 <a:ea typeface="STSong"/>
                 <a:cs typeface="STSong"/>
               </a:rPr>
-              <a:t>边界值：12 条</a:t>
+              <a:t>    12  </a:t>
             </a:r>
           </a:p>
           <a:p xmlns:a="http://schemas.openxmlformats.org/drawingml/2006/main">
@@ -3447,7 +3447,7 @@
                 <a:ea typeface="STSong"/>
                 <a:cs typeface="STSong"/>
               </a:rPr>
-              <a:t>场景与状态转换：8 条</a:t>
+              <a:t>        8  </a:t>
             </a:r>
           </a:p>
           <a:p xmlns:a="http://schemas.openxmlformats.org/drawingml/2006/main">
@@ -3470,7 +3470,7 @@
                 <a:ea typeface="STSong"/>
                 <a:cs typeface="STSong"/>
               </a:rPr>
-              <a:t>异常与回归：4 条</a:t>
+              <a:t>      4  </a:t>
             </a:r>
           </a:p>
           <a:p xmlns:a="http://schemas.openxmlformats.org/drawingml/2006/main">
@@ -3493,7 +3493,7 @@
                 <a:ea typeface="STSong"/>
                 <a:cs typeface="STSong"/>
               </a:rPr>
-              <a:t>共 36 条，自动化执行比例超过 80%</a:t>
+              <a:t>  36             80%</a:t>
             </a:r>
           </a:p>
         </p:txBody>
@@ -3503,7 +3503,7 @@
           <p:cNvPr id="4" name="">
             <a:extLst xmlns:a="http://schemas.openxmlformats.org/drawingml/2006/main">
               <a:ext uri="{FF2B5EF4-FFF2-40B4-BE49-F238E27FC236}">
-                <a16:creationId xmlns:a16="http://schemas.microsoft.com/office/drawing/2014/main" id="{B2CD6400-3102-4495-B7E5-18925ADD0AD5}"/>
+                <a16:creationId xmlns:a16="http://schemas.microsoft.com/office/drawing/2014/main" id="{76D2968E-B4A4-41AF-A34A-DE3E1BFDFC9A}"/>
               </a:ext>
             </a:extLst>
           </p:cNvPr>
@@ -3556,7 +3556,7 @@
     </p:spTree>
     <p:extLst>
       <p:ext uri="{BB962C8B-B14F-4D97-AF65-F5344CB8AC3E}">
-        <p14:creationId xmlns:p14="http://schemas.microsoft.com/office/powerpoint/2010/main" val="2133793946"/>
+        <p14:creationId xmlns:p14="http://schemas.microsoft.com/office/powerpoint/2010/main" val="1046039642"/>
       </p:ext>
     </p:extLst>
   </p:cSld>
@@ -3587,7 +3587,7 @@
           <p:cNvPr id="5" name="">
             <a:extLst xmlns:a="http://schemas.openxmlformats.org/drawingml/2006/main">
               <a:ext uri="{FF2B5EF4-FFF2-40B4-BE49-F238E27FC236}">
-                <a16:creationId xmlns:a16="http://schemas.microsoft.com/office/drawing/2014/main" id="{5029BEF9-747E-4664-B870-D1F4331F8342}"/>
+                <a16:creationId xmlns:a16="http://schemas.microsoft.com/office/drawing/2014/main" id="{5ACA9FED-A2E8-4CD9-942A-5EDAE57DE7B5}"/>
               </a:ext>
             </a:extLst>
           </p:cNvPr>
@@ -3632,7 +3632,7 @@
                 <a:ea typeface="STSong"/>
                 <a:cs typeface="STSong"/>
               </a:rPr>
-              <a:t>自动化执行路径</a:t>
+              <a:t>Automated Execution</a:t>
             </a:r>
           </a:p>
         </p:txBody>
@@ -3642,7 +3642,7 @@
           <p:cNvPr id="2" name="">
             <a:extLst xmlns:a="http://schemas.openxmlformats.org/drawingml/2006/main">
               <a:ext uri="{FF2B5EF4-FFF2-40B4-BE49-F238E27FC236}">
-                <a16:creationId xmlns:a16="http://schemas.microsoft.com/office/drawing/2014/main" id="{F3C1D944-B645-49F5-B60E-8CF3C442996B}"/>
+                <a16:creationId xmlns:a16="http://schemas.microsoft.com/office/drawing/2014/main" id="{37FCFB99-1A57-4FF2-9C45-1B37180B6B18}"/>
               </a:ext>
             </a:extLst>
           </p:cNvPr>
@@ -3687,7 +3687,7 @@
                 <a:ea typeface="STSong"/>
                 <a:cs typeface="STSong"/>
               </a:rPr>
-              <a:t>一条命令把清单变成可重复证据</a:t>
+              <a:t>              </a:t>
             </a:r>
           </a:p>
         </p:txBody>
@@ -3697,7 +3697,7 @@
           <p:cNvPr id="3" name="">
             <a:extLst xmlns:a="http://schemas.openxmlformats.org/drawingml/2006/main">
               <a:ext uri="{FF2B5EF4-FFF2-40B4-BE49-F238E27FC236}">
-                <a16:creationId xmlns:a16="http://schemas.microsoft.com/office/drawing/2014/main" id="{5C09412B-D266-47C0-96C2-B89FF0182057}"/>
+                <a16:creationId xmlns:a16="http://schemas.microsoft.com/office/drawing/2014/main" id="{F58B8F83-FF29-4D17-83F4-821223F84389}"/>
               </a:ext>
             </a:extLst>
           </p:cNvPr>
@@ -3742,7 +3742,7 @@
                 <a:ea typeface="STSong"/>
                 <a:cs typeface="STSong"/>
               </a:rPr>
-              <a:t>pytest 参数化数据驱动</a:t>
+              <a:t>pytest        </a:t>
             </a:r>
           </a:p>
           <a:p xmlns:a="http://schemas.openxmlformats.org/drawingml/2006/main">
@@ -3765,7 +3765,7 @@
                 <a:ea typeface="STSong"/>
                 <a:cs typeface="STSong"/>
               </a:rPr>
-              <a:t>fixture 统一时间与时区</a:t>
+              <a:t>fixture        </a:t>
             </a:r>
           </a:p>
           <a:p xmlns:a="http://schemas.openxmlformats.org/drawingml/2006/main">
@@ -3788,7 +3788,7 @@
                 <a:ea typeface="STSong"/>
                 <a:cs typeface="STSong"/>
               </a:rPr>
-              <a:t>smoke / boundary / regression 标记</a:t>
+              <a:t>smoke / boundary / regression   </a:t>
             </a:r>
           </a:p>
           <a:p xmlns:a="http://schemas.openxmlformats.org/drawingml/2006/main">
@@ -3811,7 +3811,7 @@
                 <a:ea typeface="STSong"/>
                 <a:cs typeface="STSong"/>
               </a:rPr>
-              <a:t>运行：python -m pytest -q</a:t>
+              <a:t>   python -m pytest -q</a:t>
             </a:r>
           </a:p>
         </p:txBody>
@@ -3821,7 +3821,7 @@
           <p:cNvPr id="4" name="">
             <a:extLst xmlns:a="http://schemas.openxmlformats.org/drawingml/2006/main">
               <a:ext uri="{FF2B5EF4-FFF2-40B4-BE49-F238E27FC236}">
-                <a16:creationId xmlns:a16="http://schemas.microsoft.com/office/drawing/2014/main" id="{6818528A-061C-41E7-8D59-98FA93C1A67F}"/>
+                <a16:creationId xmlns:a16="http://schemas.microsoft.com/office/drawing/2014/main" id="{0D9F4F20-546D-4FF3-9216-B80DC9A4F2F4}"/>
               </a:ext>
             </a:extLst>
           </p:cNvPr>
@@ -3874,7 +3874,7 @@
     </p:spTree>
     <p:extLst>
       <p:ext uri="{BB962C8B-B14F-4D97-AF65-F5344CB8AC3E}">
-        <p14:creationId xmlns:p14="http://schemas.microsoft.com/office/powerpoint/2010/main" val="1469437828"/>
+        <p14:creationId xmlns:p14="http://schemas.microsoft.com/office/powerpoint/2010/main" val="2094570406"/>
       </p:ext>
     </p:extLst>
   </p:cSld>
@@ -3905,7 +3905,7 @@
           <p:cNvPr id="5" name="">
             <a:extLst xmlns:a="http://schemas.openxmlformats.org/drawingml/2006/main">
               <a:ext uri="{FF2B5EF4-FFF2-40B4-BE49-F238E27FC236}">
-                <a16:creationId xmlns:a16="http://schemas.microsoft.com/office/drawing/2014/main" id="{AFD040FA-67AA-490E-AC5F-6950E66EA1EE}"/>
+                <a16:creationId xmlns:a16="http://schemas.microsoft.com/office/drawing/2014/main" id="{B6B99F6F-420E-4360-ACC1-8520A9B6F856}"/>
               </a:ext>
             </a:extLst>
           </p:cNvPr>
@@ -3950,7 +3950,7 @@
                 <a:ea typeface="STSong"/>
                 <a:cs typeface="STSong"/>
               </a:rPr>
-              <a:t>用例清单结构</a:t>
+              <a:t>Test Case Design</a:t>
             </a:r>
           </a:p>
         </p:txBody>
@@ -3960,7 +3960,7 @@
           <p:cNvPr id="2" name="">
             <a:extLst xmlns:a="http://schemas.openxmlformats.org/drawingml/2006/main">
               <a:ext uri="{FF2B5EF4-FFF2-40B4-BE49-F238E27FC236}">
-                <a16:creationId xmlns:a16="http://schemas.microsoft.com/office/drawing/2014/main" id="{B78FA017-3118-4E4D-A084-7588304CA445}"/>
+                <a16:creationId xmlns:a16="http://schemas.microsoft.com/office/drawing/2014/main" id="{143D50E4-DE61-478D-B094-7FBEFCE0A185}"/>
               </a:ext>
             </a:extLst>
           </p:cNvPr>
@@ -4005,7 +4005,7 @@
                 <a:ea typeface="STSong"/>
                 <a:cs typeface="STSong"/>
               </a:rPr>
-              <a:t>每条用例都能追溯到函数和结果</a:t>
+              <a:t>              </a:t>
             </a:r>
           </a:p>
         </p:txBody>
@@ -4015,7 +4015,7 @@
           <p:cNvPr id="3" name="">
             <a:extLst xmlns:a="http://schemas.openxmlformats.org/drawingml/2006/main">
               <a:ext uri="{FF2B5EF4-FFF2-40B4-BE49-F238E27FC236}">
-                <a16:creationId xmlns:a16="http://schemas.microsoft.com/office/drawing/2014/main" id="{A495611F-D45D-4A96-A312-5852D6D32C13}"/>
+                <a16:creationId xmlns:a16="http://schemas.microsoft.com/office/drawing/2014/main" id="{D58BE55C-44C0-46FF-A324-794DEE3D5264}"/>
               </a:ext>
             </a:extLst>
           </p:cNvPr>
@@ -4060,7 +4060,7 @@
                 <a:ea typeface="STSong"/>
                 <a:cs typeface="STSong"/>
               </a:rPr>
-              <a:t>编号 CRON-UT-001～036</a:t>
+              <a:t>   CRON-UT-001 036</a:t>
             </a:r>
           </a:p>
           <a:p xmlns:a="http://schemas.openxmlformats.org/drawingml/2006/main">
@@ -4083,7 +4083,7 @@
                 <a:ea typeface="STSong"/>
                 <a:cs typeface="STSong"/>
               </a:rPr>
-              <a:t>字段包含：输入、步骤、预期、实际、状态、设计方法</a:t>
+              <a:t>                        </a:t>
             </a:r>
           </a:p>
           <a:p xmlns:a="http://schemas.openxmlformats.org/drawingml/2006/main">
@@ -4106,7 +4106,7 @@
                 <a:ea typeface="STSong"/>
                 <a:cs typeface="STSong"/>
               </a:rPr>
-              <a:t>测试数据保存在 testdata/cron_cases.json</a:t>
+              <a:t>        testdata/cron_cases.json</a:t>
             </a:r>
           </a:p>
           <a:p xmlns:a="http://schemas.openxmlformats.org/drawingml/2006/main">
@@ -4129,7 +4129,7 @@
                 <a:ea typeface="STSong"/>
                 <a:cs typeface="STSong"/>
               </a:rPr>
-              <a:t>清单模板：附录1-测试用例清单.xlsx</a:t>
+              <a:t>       1-      .xlsx</a:t>
             </a:r>
           </a:p>
         </p:txBody>
@@ -4139,7 +4139,7 @@
           <p:cNvPr id="4" name="">
             <a:extLst xmlns:a="http://schemas.openxmlformats.org/drawingml/2006/main">
               <a:ext uri="{FF2B5EF4-FFF2-40B4-BE49-F238E27FC236}">
-                <a16:creationId xmlns:a16="http://schemas.microsoft.com/office/drawing/2014/main" id="{0A5ECD12-F320-41AA-9935-59F98F4E3E74}"/>
+                <a16:creationId xmlns:a16="http://schemas.microsoft.com/office/drawing/2014/main" id="{A0FDABD5-C66E-49E9-B862-50D38CD93F8E}"/>
               </a:ext>
             </a:extLst>
           </p:cNvPr>
@@ -4192,7 +4192,7 @@
     </p:spTree>
     <p:extLst>
       <p:ext uri="{BB962C8B-B14F-4D97-AF65-F5344CB8AC3E}">
-        <p14:creationId xmlns:p14="http://schemas.microsoft.com/office/powerpoint/2010/main" val="2138203054"/>
+        <p14:creationId xmlns:p14="http://schemas.microsoft.com/office/powerpoint/2010/main" val="1651537985"/>
       </p:ext>
     </p:extLst>
   </p:cSld>
@@ -4223,7 +4223,7 @@
           <p:cNvPr id="5" name="">
             <a:extLst xmlns:a="http://schemas.openxmlformats.org/drawingml/2006/main">
               <a:ext uri="{FF2B5EF4-FFF2-40B4-BE49-F238E27FC236}">
-                <a16:creationId xmlns:a16="http://schemas.microsoft.com/office/drawing/2014/main" id="{F8490793-852B-497B-833B-6E4F95E71657}"/>
+                <a16:creationId xmlns:a16="http://schemas.microsoft.com/office/drawing/2014/main" id="{6F81EFFA-7873-4DB3-B66F-CA8AFFAA4055}"/>
               </a:ext>
             </a:extLst>
           </p:cNvPr>
@@ -4268,7 +4268,7 @@
                 <a:ea typeface="STSong"/>
                 <a:cs typeface="STSong"/>
               </a:rPr>
-              <a:t>缺陷复现：零步长范围</a:t>
+              <a:t>Defect Reproduction: Zero Step</a:t>
             </a:r>
           </a:p>
         </p:txBody>
@@ -4278,7 +4278,7 @@
           <p:cNvPr id="2" name="">
             <a:extLst xmlns:a="http://schemas.openxmlformats.org/drawingml/2006/main">
               <a:ext uri="{FF2B5EF4-FFF2-40B4-BE49-F238E27FC236}">
-                <a16:creationId xmlns:a16="http://schemas.microsoft.com/office/drawing/2014/main" id="{61666E31-30E8-4F88-872F-985B8B36AFB6}"/>
+                <a16:creationId xmlns:a16="http://schemas.microsoft.com/office/drawing/2014/main" id="{DAEAD128-B246-4CCA-AF5C-77879FC2CE67}"/>
               </a:ext>
             </a:extLst>
           </p:cNvPr>
@@ -4323,7 +4323,7 @@
                 <a:ea typeface="STSong"/>
                 <a:cs typeface="STSong"/>
               </a:rPr>
-              <a:t>基线版本接受了不应接受的步长输入</a:t>
+              <a:t>                </a:t>
             </a:r>
           </a:p>
         </p:txBody>
@@ -4333,7 +4333,7 @@
           <p:cNvPr id="3" name="">
             <a:extLst xmlns:a="http://schemas.openxmlformats.org/drawingml/2006/main">
               <a:ext uri="{FF2B5EF4-FFF2-40B4-BE49-F238E27FC236}">
-                <a16:creationId xmlns:a16="http://schemas.microsoft.com/office/drawing/2014/main" id="{FD5F85A5-85AA-4FDB-AE4B-6912E859BC86}"/>
+                <a16:creationId xmlns:a16="http://schemas.microsoft.com/office/drawing/2014/main" id="{E517C0B3-9EFB-4675-8B57-7F61687E052F}"/>
               </a:ext>
             </a:extLst>
           </p:cNvPr>
@@ -4378,7 +4378,7 @@
                 <a:ea typeface="STSong"/>
                 <a:cs typeface="STSong"/>
               </a:rPr>
-              <a:t>表达式：5-5/0</a:t>
+              <a:t>    5-5/0</a:t>
             </a:r>
           </a:p>
           <a:p xmlns:a="http://schemas.openxmlformats.org/drawingml/2006/main">
@@ -4401,7 +4401,7 @@
                 <a:ea typeface="STSong"/>
                 <a:cs typeface="STSong"/>
               </a:rPr>
-              <a:t>基线 6.2.2：行为异常，未稳定拒绝</a:t>
+              <a:t>   6.2.2           </a:t>
             </a:r>
           </a:p>
           <a:p xmlns:a="http://schemas.openxmlformats.org/drawingml/2006/main">
@@ -4424,7 +4424,7 @@
                 <a:ea typeface="STSong"/>
                 <a:cs typeface="STSong"/>
               </a:rPr>
-              <a:t>修复：07dfad8 增加步长校验</a:t>
+              <a:t>   07dfad8       </a:t>
             </a:r>
           </a:p>
           <a:p xmlns:a="http://schemas.openxmlformats.org/drawingml/2006/main">
@@ -4447,7 +4447,7 @@
                 <a:ea typeface="STSong"/>
                 <a:cs typeface="STSong"/>
               </a:rPr>
-              <a:t>回归：零步长稳定抛出异常，合法步长继续通过</a:t>
+              <a:t>                     </a:t>
             </a:r>
           </a:p>
         </p:txBody>
@@ -4457,7 +4457,7 @@
           <p:cNvPr id="4" name="">
             <a:extLst xmlns:a="http://schemas.openxmlformats.org/drawingml/2006/main">
               <a:ext uri="{FF2B5EF4-FFF2-40B4-BE49-F238E27FC236}">
-                <a16:creationId xmlns:a16="http://schemas.microsoft.com/office/drawing/2014/main" id="{080C0B37-867F-4557-B453-D633D573AB6D}"/>
+                <a16:creationId xmlns:a16="http://schemas.microsoft.com/office/drawing/2014/main" id="{764504D0-5A75-49C4-B161-33B4EE727EBB}"/>
               </a:ext>
             </a:extLst>
           </p:cNvPr>
@@ -4510,7 +4510,7 @@
     </p:spTree>
     <p:extLst>
       <p:ext uri="{BB962C8B-B14F-4D97-AF65-F5344CB8AC3E}">
-        <p14:creationId xmlns:p14="http://schemas.microsoft.com/office/powerpoint/2010/main" val="1095526866"/>
+        <p14:creationId xmlns:p14="http://schemas.microsoft.com/office/powerpoint/2010/main" val="1198622387"/>
       </p:ext>
     </p:extLst>
   </p:cSld>
@@ -4541,7 +4541,7 @@
           <p:cNvPr id="5" name="">
             <a:extLst xmlns:a="http://schemas.openxmlformats.org/drawingml/2006/main">
               <a:ext uri="{FF2B5EF4-FFF2-40B4-BE49-F238E27FC236}">
-                <a16:creationId xmlns:a16="http://schemas.microsoft.com/office/drawing/2014/main" id="{B696F0FF-E7FA-4867-9115-E9AC13F2353D}"/>
+                <a16:creationId xmlns:a16="http://schemas.microsoft.com/office/drawing/2014/main" id="{DEF65693-0684-4FD5-9E45-6C9CA9458E3C}"/>
               </a:ext>
             </a:extLst>
           </p:cNvPr>
@@ -4586,7 +4586,7 @@
                 <a:ea typeface="STSong"/>
                 <a:cs typeface="STSong"/>
               </a:rPr>
-              <a:t>缺陷闭环：月份与 Sunday 边界</a:t>
+              <a:t>Defect Closure: Month and Sunday</a:t>
             </a:r>
           </a:p>
         </p:txBody>
@@ -4596,7 +4596,7 @@
           <p:cNvPr id="2" name="">
             <a:extLst xmlns:a="http://schemas.openxmlformats.org/drawingml/2006/main">
               <a:ext uri="{FF2B5EF4-FFF2-40B4-BE49-F238E27FC236}">
-                <a16:creationId xmlns:a16="http://schemas.microsoft.com/office/drawing/2014/main" id="{F069D21A-0635-44F0-8E4F-5F39B6E7AD59}"/>
+                <a16:creationId xmlns:a16="http://schemas.microsoft.com/office/drawing/2014/main" id="{1168207D-15A7-4716-B422-EA57CDD0FEE9}"/>
               </a:ext>
             </a:extLst>
           </p:cNvPr>
@@ -4641,7 +4641,7 @@
                 <a:ea typeface="STSong"/>
                 <a:cs typeface="STSong"/>
               </a:rPr>
-              <a:t>公开记录提供证据，本地回归证明修复有效</a:t>
+              <a:t>                   </a:t>
             </a:r>
           </a:p>
         </p:txBody>
@@ -4651,7 +4651,7 @@
           <p:cNvPr id="3" name="">
             <a:extLst xmlns:a="http://schemas.openxmlformats.org/drawingml/2006/main">
               <a:ext uri="{FF2B5EF4-FFF2-40B4-BE49-F238E27FC236}">
-                <a16:creationId xmlns:a16="http://schemas.microsoft.com/office/drawing/2014/main" id="{1DCB39D2-CBDC-46AC-905A-1FEF443DCE73}"/>
+                <a16:creationId xmlns:a16="http://schemas.microsoft.com/office/drawing/2014/main" id="{F45AE5F6-71AE-4204-B9A2-2F90653F3CB8}"/>
               </a:ext>
             </a:extLst>
           </p:cNvPr>
@@ -4696,7 +4696,7 @@
                 <a:ea typeface="STSong"/>
                 <a:cs typeface="STSong"/>
               </a:rPr>
-              <a:t>月份边界：issue #235，对应修复 101f39e</a:t>
+              <a:t>     issue #235      101f39e</a:t>
             </a:r>
           </a:p>
           <a:p xmlns:a="http://schemas.openxmlformats.org/drawingml/2006/main">
@@ -4719,7 +4719,7 @@
                 <a:ea typeface="STSong"/>
                 <a:cs typeface="STSong"/>
               </a:rPr>
-              <a:t>Sunday 步进：issue #239，对应修复 10e9bb6</a:t>
+              <a:t>Sunday    issue #239      10e9bb6</a:t>
             </a:r>
           </a:p>
           <a:p xmlns:a="http://schemas.openxmlformats.org/drawingml/2006/main">
@@ -4742,7 +4742,7 @@
                 <a:ea typeface="STSong"/>
                 <a:cs typeface="STSong"/>
               </a:rPr>
-              <a:t>分别覆盖 1 月、12 月、跨年和 Saturday→Sunday</a:t>
+              <a:t>     1   12       Saturday Sunday</a:t>
             </a:r>
           </a:p>
         </p:txBody>
@@ -4752,7 +4752,7 @@
           <p:cNvPr id="4" name="">
             <a:extLst xmlns:a="http://schemas.openxmlformats.org/drawingml/2006/main">
               <a:ext uri="{FF2B5EF4-FFF2-40B4-BE49-F238E27FC236}">
-                <a16:creationId xmlns:a16="http://schemas.microsoft.com/office/drawing/2014/main" id="{9B828F8F-DF1E-4399-91FF-E8C62B987CD7}"/>
+                <a16:creationId xmlns:a16="http://schemas.microsoft.com/office/drawing/2014/main" id="{8063F3D5-4892-422E-BD2C-CCDD4B8D01B4}"/>
               </a:ext>
             </a:extLst>
           </p:cNvPr>
@@ -4805,7 +4805,7 @@
     </p:spTree>
     <p:extLst>
       <p:ext uri="{BB962C8B-B14F-4D97-AF65-F5344CB8AC3E}">
-        <p14:creationId xmlns:p14="http://schemas.microsoft.com/office/powerpoint/2010/main" val="1600532929"/>
+        <p14:creationId xmlns:p14="http://schemas.microsoft.com/office/powerpoint/2010/main" val="1841340560"/>
       </p:ext>
     </p:extLst>
   </p:cSld>
@@ -4836,7 +4836,7 @@
           <p:cNvPr id="5" name="">
             <a:extLst xmlns:a="http://schemas.openxmlformats.org/drawingml/2006/main">
               <a:ext uri="{FF2B5EF4-FFF2-40B4-BE49-F238E27FC236}">
-                <a16:creationId xmlns:a16="http://schemas.microsoft.com/office/drawing/2014/main" id="{B9408596-9749-4A30-8289-9B4725B69B9A}"/>
+                <a16:creationId xmlns:a16="http://schemas.microsoft.com/office/drawing/2014/main" id="{F4436FEC-F02A-4452-BD14-53924C283B6D}"/>
               </a:ext>
             </a:extLst>
           </p:cNvPr>
@@ -4881,7 +4881,7 @@
                 <a:ea typeface="STSong"/>
                 <a:cs typeface="STSong"/>
               </a:rPr>
-              <a:t>执行结果</a:t>
+              <a:t>Execution Results</a:t>
             </a:r>
           </a:p>
         </p:txBody>
@@ -4891,7 +4891,7 @@
           <p:cNvPr id="2" name="">
             <a:extLst xmlns:a="http://schemas.openxmlformats.org/drawingml/2006/main">
               <a:ext uri="{FF2B5EF4-FFF2-40B4-BE49-F238E27FC236}">
-                <a16:creationId xmlns:a16="http://schemas.microsoft.com/office/drawing/2014/main" id="{56E3C495-AC39-41AB-AE0E-7291317F890E}"/>
+                <a16:creationId xmlns:a16="http://schemas.microsoft.com/office/drawing/2014/main" id="{FD38CF8C-BFBB-4526-862A-2B44611A0298}"/>
               </a:ext>
             </a:extLst>
           </p:cNvPr>
@@ -4936,7 +4936,7 @@
                 <a:ea typeface="STSong"/>
                 <a:cs typeface="STSong"/>
               </a:rPr>
-              <a:t>测试通过，覆盖率用于定位后续风险</a:t>
+              <a:t>                </a:t>
             </a:r>
           </a:p>
         </p:txBody>
@@ -4946,7 +4946,7 @@
           <p:cNvPr id="3" name="">
             <a:extLst xmlns:a="http://schemas.openxmlformats.org/drawingml/2006/main">
               <a:ext uri="{FF2B5EF4-FFF2-40B4-BE49-F238E27FC236}">
-                <a16:creationId xmlns:a16="http://schemas.microsoft.com/office/drawing/2014/main" id="{4071480A-13F7-47F4-8B45-DC9294E403AD}"/>
+                <a16:creationId xmlns:a16="http://schemas.microsoft.com/office/drawing/2014/main" id="{5F0DD1A8-7C77-494A-95AA-6A8B7E9BD58D}"/>
               </a:ext>
             </a:extLst>
           </p:cNvPr>
@@ -5014,7 +5014,7 @@
                 <a:ea typeface="STSong"/>
                 <a:cs typeface="STSong"/>
               </a:rPr>
-              <a:t>覆盖率：55%（当前结果，如实记录）</a:t>
+              <a:t>    55%           </a:t>
             </a:r>
           </a:p>
           <a:p xmlns:a="http://schemas.openxmlformats.org/drawingml/2006/main">
@@ -5037,7 +5037,7 @@
                 <a:ea typeface="STSong"/>
                 <a:cs typeface="STSong"/>
               </a:rPr>
-              <a:t>三项历史缺陷均完成复现、修复和回归</a:t>
+              <a:t>                 </a:t>
             </a:r>
           </a:p>
           <a:p xmlns:a="http://schemas.openxmlformats.org/drawingml/2006/main">
@@ -5060,7 +5060,7 @@
                 <a:ea typeface="STSong"/>
                 <a:cs typeface="STSong"/>
               </a:rPr>
-              <a:t>未把覆盖率当作质量结论，后续补充未覆盖分支</a:t>
+              <a:t>                     </a:t>
             </a:r>
           </a:p>
         </p:txBody>
@@ -5070,7 +5070,7 @@
           <p:cNvPr id="4" name="">
             <a:extLst xmlns:a="http://schemas.openxmlformats.org/drawingml/2006/main">
               <a:ext uri="{FF2B5EF4-FFF2-40B4-BE49-F238E27FC236}">
-                <a16:creationId xmlns:a16="http://schemas.microsoft.com/office/drawing/2014/main" id="{83545A38-EACF-447C-8004-F5464C6733CE}"/>
+                <a16:creationId xmlns:a16="http://schemas.microsoft.com/office/drawing/2014/main" id="{96911B20-856C-45B5-B143-E6E1277F7F38}"/>
               </a:ext>
             </a:extLst>
           </p:cNvPr>
@@ -5123,7 +5123,7 @@
     </p:spTree>
     <p:extLst>
       <p:ext uri="{BB962C8B-B14F-4D97-AF65-F5344CB8AC3E}">
-        <p14:creationId xmlns:p14="http://schemas.microsoft.com/office/powerpoint/2010/main" val="2071754953"/>
+        <p14:creationId xmlns:p14="http://schemas.microsoft.com/office/powerpoint/2010/main" val="1572911598"/>
       </p:ext>
     </p:extLst>
   </p:cSld>

</xml_diff>